<commit_message>
fix: complete yield discovery and refresh release materials
</commit_message>
<xml_diff>
--- a/public/presentation/rwa-lens-pitch.pptx
+++ b/public/presentation/rwa-lens-pitch.pptx
@@ -514,11 +514,13 @@
           <a:p>
             <a:r>
               <a:rPr lang="en-US" dirty="0"/>
-              <a:t>Open with the product, not a market statistic. RWA Lens gives teams a clear view of the public Solana token data behind an asset: its identity, units, display conversion and observable controls. The live product is a read-only inspector on Solana mainnet. This is an invitation to use it and shape the next integrations.
+              <a:t>RWA Lens helps teams inspect the public Solana state behind a token, discover its liquidity and carry the evidence into their workflow. The live mainnet product combines a read-only inspector, a tokenized-asset yield screener and local receipts. It is also installable as a PWA. Invite the audience to use the product and shape the next integrations.
 Sources and Q&amp;A: rwa-lens-presenter-notes.md.
 Live product: https://rwalensonsolana.vercel.app
 Guided demo: https://rwalensonsolana.vercel.app/demo
 Technical breakdown: https://rwalensonsolana.vercel.app/technical
+Yield screener: https://rwalensonsolana.vercel.app/yield
+Issuer reserve reports: https://ondo.finance/usdy
 Source repository: https://github.com/operatoruplift/rwa-lens
 USDY mint address registry: https://docs.ondo.finance/addresses
 Issuer USDY description: https://docs.ondo.finance/general-access-products/usdy/basics
@@ -615,6 +617,8 @@
 Live product: https://rwalensonsolana.vercel.app
 Guided demo: https://rwalensonsolana.vercel.app/demo
 Technical breakdown: https://rwalensonsolana.vercel.app/technical
+Yield screener: https://rwalensonsolana.vercel.app/yield
+Issuer reserve reports: https://ondo.finance/usdy
 Source repository: https://github.com/operatoruplift/rwa-lens
 USDY mint address registry: https://docs.ondo.finance/addresses
 Issuer USDY description: https://docs.ondo.finance/general-access-products/usdy/basics
@@ -706,11 +710,13 @@
           <a:p>
             <a:r>
               <a:rPr lang="en-US" dirty="0"/>
-              <a:t>The current product supports public mainnet token inspection and local evidence exports. Engineering verification covers accounting, decoders, request validation, failure states, keyboard and responsive UI paths. The next step is partner workflow validation. Monitoring, shared retained history and productized external integrations are roadmap items. These are priorities, not dated delivery commitments. Production RPC availability remains an operational dependency.
+              <a:t>The current public product supports mainnet token inspection, tokenized-asset pool discovery, issuer reserve links, local evidence exports and an installable PWA. Engineering verification covers accounting, decoders, request validation, failure states, keyboard and responsive UI paths. The Android and Seeker Web Shell is source-ready; on-device validation and publishing remain separate steps. The optional wallet-signed USDC deploy path is off pending a funded real-wallet send and operator activation. Partner pilots, monitoring and shared retained history are next-stage work, not claimed adoption or dated commitments. RPC and market-data availability remain operational dependencies.
 Sources and Q&amp;A: rwa-lens-presenter-notes.md.
 Live product: https://rwalensonsolana.vercel.app
 Guided demo: https://rwalensonsolana.vercel.app/demo
 Technical breakdown: https://rwalensonsolana.vercel.app/technical
+Yield screener: https://rwalensonsolana.vercel.app/yield
+Issuer reserve reports: https://ondo.finance/usdy
 Source repository: https://github.com/operatoruplift/rwa-lens
 USDY mint address registry: https://docs.ondo.finance/addresses
 Issuer USDY description: https://docs.ondo.finance/general-access-products/usdy/basics
@@ -807,6 +813,8 @@
 Live product: https://rwalensonsolana.vercel.app
 Guided demo: https://rwalensonsolana.vercel.app/demo
 Technical breakdown: https://rwalensonsolana.vercel.app/technical
+Yield screener: https://rwalensonsolana.vercel.app/yield
+Issuer reserve reports: https://ondo.finance/usdy
 Source repository: https://github.com/operatoruplift/rwa-lens
 USDY mint address registry: https://docs.ondo.finance/addresses
 Issuer USDY description: https://docs.ondo.finance/general-access-products/usdy/basics
@@ -903,6 +911,8 @@
 Live product: https://rwalensonsolana.vercel.app
 Guided demo: https://rwalensonsolana.vercel.app/demo
 Technical breakdown: https://rwalensonsolana.vercel.app/technical
+Yield screener: https://rwalensonsolana.vercel.app/yield
+Issuer reserve reports: https://ondo.finance/usdy
 Source repository: https://github.com/operatoruplift/rwa-lens
 USDY mint address registry: https://docs.ondo.finance/addresses
 Issuer USDY description: https://docs.ondo.finance/general-access-products/usdy/basics
@@ -999,6 +1009,8 @@
 Live product: https://rwalensonsolana.vercel.app
 Guided demo: https://rwalensonsolana.vercel.app/demo
 Technical breakdown: https://rwalensonsolana.vercel.app/technical
+Yield screener: https://rwalensonsolana.vercel.app/yield
+Issuer reserve reports: https://ondo.finance/usdy
 Source repository: https://github.com/operatoruplift/rwa-lens
 USDY mint address registry: https://docs.ondo.finance/addresses
 Issuer USDY description: https://docs.ondo.finance/general-access-products/usdy/basics
@@ -1095,6 +1107,8 @@
 Live product: https://rwalensonsolana.vercel.app
 Guided demo: https://rwalensonsolana.vercel.app/demo
 Technical breakdown: https://rwalensonsolana.vercel.app/technical
+Yield screener: https://rwalensonsolana.vercel.app/yield
+Issuer reserve reports: https://ondo.finance/usdy
 Source repository: https://github.com/operatoruplift/rwa-lens
 USDY mint address registry: https://docs.ondo.finance/addresses
 Issuer USDY description: https://docs.ondo.finance/general-access-products/usdy/basics
@@ -1186,11 +1200,13 @@
           <a:p>
             <a:r>
               <a:rPr lang="en-US" dirty="0"/>
-              <a:t>Enter a mint and optionally a public owner address. The server validates inputs and reads the configured Solana network. The result separates identity, balances, extensions, readiness and source evidence. Export JSON for the complete structured record or CSV for tabular review. Guest inspection and local exports require no wallet. RWA Lens does not sign or submit transactions.
+              <a:t>Enter a mint and optionally a public owner address. The server validates inputs and reads the configured Solana network. The result separates identity, balances, extensions, readiness and source evidence. Export JSON for the complete structured record or CSV for tabular review. Inspection and local exports require no wallet and never sign or move assets. The separate operator-enabled USDC deploy flow is off on the public deployment; it prepares a transaction for the user to review, sign and send in their own wallet.
 Sources and Q&amp;A: rwa-lens-presenter-notes.md.
 Live product: https://rwalensonsolana.vercel.app
 Guided demo: https://rwalensonsolana.vercel.app/demo
 Technical breakdown: https://rwalensonsolana.vercel.app/technical
+Yield screener: https://rwalensonsolana.vercel.app/yield
+Issuer reserve reports: https://ondo.finance/usdy
 Source repository: https://github.com/operatoruplift/rwa-lens
 USDY mint address registry: https://docs.ondo.finance/addresses
 Issuer USDY description: https://docs.ondo.finance/general-access-products/usdy/basics
@@ -1282,11 +1298,13 @@
           <a:p>
             <a:r>
               <a:rPr lang="en-US" dirty="0"/>
-              <a:t>Open https://rwalensonsolana.vercel.app/demo and run the USDY inspection. The official mint is A1KLoBrKBde8Ty9qtNQUtq3C2ortoC3u7twggz7sEto6. Confirm the full mint address and legacy SPL Token program. Review identity, authorities, evidence and export. Explain that USDY’s legacy SPL program is separate from the product’s Token-2022 support. Issuer descriptions provide attribution; they do not independently establish backing, legal rights, eligibility or investment performance. Keep the live result visible if the provider reports an unavailable or partial observation.
+              <a:t>Open https://rwalensonsolana.vercel.app/demo and run the USDY inspection. The official mint is A1KLoBrKBde8Ty9qtNQUtq3C2ortoC3u7twggz7sEto6. Confirm the full mint address and legacy SPL Token program. Review identity, authorities, evidence and export. Explain that USDY’s legacy SPL program is separate from the product’s Token-2022 support. Issuer descriptions provide attribution; they do not independently establish backing, legal rights, eligibility or investment performance. Keep the live result visible if the provider reports an unavailable or partial observation. After exporting, open the issuer reserve link and /yield. Filter by issuer, pair and liquidity; follow a row back to the exact mint in the inspector. Market figures remain separate from the chain observation and historical fees do not promise future returns.
 Sources and Q&amp;A: rwa-lens-presenter-notes.md.
 Live product: https://rwalensonsolana.vercel.app
 Guided demo: https://rwalensonsolana.vercel.app/demo
 Technical breakdown: https://rwalensonsolana.vercel.app/technical
+Yield screener: https://rwalensonsolana.vercel.app/yield
+Issuer reserve reports: https://ondo.finance/usdy
 Source repository: https://github.com/operatoruplift/rwa-lens
 USDY mint address registry: https://docs.ondo.finance/addresses
 Issuer USDY description: https://docs.ondo.finance/general-access-products/usdy/basics
@@ -1383,6 +1401,8 @@
 Live product: https://rwalensonsolana.vercel.app
 Guided demo: https://rwalensonsolana.vercel.app/demo
 Technical breakdown: https://rwalensonsolana.vercel.app/technical
+Yield screener: https://rwalensonsolana.vercel.app/yield
+Issuer reserve reports: https://ondo.finance/usdy
 Source repository: https://github.com/operatoruplift/rwa-lens
 USDY mint address registry: https://docs.ondo.finance/addresses
 Issuer USDY description: https://docs.ondo.finance/general-access-products/usdy/basics
@@ -1479,6 +1499,8 @@
 Live product: https://rwalensonsolana.vercel.app
 Guided demo: https://rwalensonsolana.vercel.app/demo
 Technical breakdown: https://rwalensonsolana.vercel.app/technical
+Yield screener: https://rwalensonsolana.vercel.app/yield
+Issuer reserve reports: https://ondo.finance/usdy
 Source repository: https://github.com/operatoruplift/rwa-lens
 USDY mint address registry: https://docs.ondo.finance/addresses
 Issuer USDY description: https://docs.ondo.finance/general-access-products/usdy/basics
@@ -1570,11 +1592,13 @@
           <a:p>
             <a:r>
               <a:rPr lang="en-US" dirty="0"/>
-              <a:t>The Next.js interface calls a validated server route. Bounded Solana RPC reads retrieve mint data, Clock and optional owner accounts. Official Solana codecs drive token and extension decoding. The result preserves source information, observation time, per-read context slots and incomplete states. Requests have timeout, retry and size bounds. Metadata retrieval is explicit and allowlisted, with private-address rejection and pinned connections. Secrets stay on the server. The separate reads do not form an atomic snapshot.
+              <a:t>The Next.js interface calls a validated server route. Bounded Solana RPC reads retrieve mint data, Clock and optional owner accounts. Official Solana codecs drive token and extension decoding. The result preserves source information, observation time, per-read context slots and incomplete states. Requests have timeout, retry and size bounds. Metadata retrieval is explicit and allowlisted, with private-address rejection and pinned connections. Secrets stay on the server. The separate reads do not form an atomic snapshot. A separate market-data pipeline reads the xStocks catalog and Meteora pools through bounded HTTPS requests. Cached snapshots expose their freshness. Reserve badges link recorded issuer reports without treating them as verified backing. The optional deploy pipeline prepares an unsigned Jupiter swap plus Meteora deposit, applies instruction and spend checks and runs a mainnet preflight before wallet review. It is off in the public deployment.
 Sources and Q&amp;A: rwa-lens-presenter-notes.md.
 Live product: https://rwalensonsolana.vercel.app
 Guided demo: https://rwalensonsolana.vercel.app/demo
 Technical breakdown: https://rwalensonsolana.vercel.app/technical
+Yield screener: https://rwalensonsolana.vercel.app/yield
+Issuer reserve reports: https://ondo.finance/usdy
 Source repository: https://github.com/operatoruplift/rwa-lens
 USDY mint address registry: https://docs.ondo.finance/addresses
 Issuer USDY description: https://docs.ondo.finance/general-access-products/usdy/basics
@@ -1666,11 +1690,13 @@
           <a:p>
             <a:r>
               <a:rPr lang="en-US" dirty="0"/>
-              <a:t>The differentiation is the combination: amount reconciliation, controls explained in context and a portable observation. This is complementary to block explorers, issuer documentation and wallet interfaces. We are not claiming that other products cannot provide these features. The product’s focus is making the investigation easier to complete and easier to discuss across teams.
+              <a:t>The live yield screener shows Meteora DLMM pools holding supported tokenized assets, with TVL, volume, fees and issuer-reported market status. Filters live in the URL and each row opens the exact mint in the inspector. Reserve badges link issuer-published reports; RWA Lens does not read, audit or verify those reports. Market data remains outside the token observation and its exported receipt. Historical fee APY is not a promised return. The PWA is installable; Android and Seeker Web Shell source is included, while release signing, real-device verification and store publishing remain pending.
 Sources and Q&amp;A: rwa-lens-presenter-notes.md.
 Live product: https://rwalensonsolana.vercel.app
 Guided demo: https://rwalensonsolana.vercel.app/demo
 Technical breakdown: https://rwalensonsolana.vercel.app/technical
+Yield screener: https://rwalensonsolana.vercel.app/yield
+Issuer reserve reports: https://ondo.finance/usdy
 Source repository: https://github.com/operatoruplift/rwa-lens
 USDY mint address registry: https://docs.ondo.finance/addresses
 Issuer USDY description: https://docs.ondo.finance/general-access-products/usdy/basics
@@ -2489,7 +2515,7 @@
                 <a:ea typeface="Inter" pitchFamily="34" charset="-122"/>
                 <a:cs typeface="Inter" pitchFamily="34" charset="-120"/>
               </a:rPr>
-              <a:t>READ-ONLY · MAINNET</a:t>
+              <a:t>INSPECT · DISCOVER · MAINNET</a:t>
             </a:r>
             <a:endParaRPr lang="en-US" sz="1050" dirty="0"/>
           </a:p>
@@ -3950,7 +3976,7 @@
                 <a:ea typeface="Inter" pitchFamily="34" charset="-122"/>
                 <a:cs typeface="Inter" pitchFamily="34" charset="-120"/>
               </a:rPr>
-              <a:t>Inspect + export</a:t>
+              <a:t>Inspect + discover</a:t>
             </a:r>
             <a:endParaRPr lang="en-US" sz="2300" dirty="0"/>
           </a:p>
@@ -3992,7 +4018,7 @@
                 <a:ea typeface="Inter" pitchFamily="34" charset="-122"/>
                 <a:cs typeface="Inter" pitchFamily="34" charset="-120"/>
               </a:rPr>
-              <a:t>Mainnet reads, token decoding and local evidence.</a:t>
+              <a:t>Mainnet reads, pool discovery, receipts and installable PWA.</a:t>
             </a:r>
             <a:endParaRPr lang="en-US" sz="1600" dirty="0"/>
           </a:p>
@@ -12701,7 +12727,7 @@
                 <a:ea typeface="Inter" pitchFamily="34" charset="-122"/>
                 <a:cs typeface="Inter" pitchFamily="34" charset="-120"/>
               </a:rPr>
-              <a:t>More context.</a:t>
+              <a:t>Know the token.</a:t>
             </a:r>
             <a:endParaRPr lang="en-US" sz="4300" dirty="0"/>
           </a:p>
@@ -12740,7 +12766,7 @@
                 <a:ea typeface="Inter" pitchFamily="34" charset="-122"/>
                 <a:cs typeface="Inter" pitchFamily="34" charset="-120"/>
               </a:rPr>
-              <a:t>Less guesswork.</a:t>
+              <a:t>See the market.</a:t>
             </a:r>
             <a:endParaRPr lang="en-US" sz="4300" dirty="0"/>
           </a:p>
@@ -12779,7 +12805,7 @@
                 <a:ea typeface="Inter" pitchFamily="34" charset="-122"/>
                 <a:cs typeface="Inter" pitchFamily="34" charset="-120"/>
               </a:rPr>
-              <a:t>A focused investigation workflow for token operations.</a:t>
+              <a:t>From token evidence to liquidity discovery.</a:t>
             </a:r>
             <a:endParaRPr lang="en-US" sz="1700" dirty="0"/>
           </a:p>
@@ -12841,7 +12867,7 @@
                 <a:ea typeface="Inter" pitchFamily="34" charset="-122"/>
                 <a:cs typeface="Inter" pitchFamily="34" charset="-120"/>
               </a:rPr>
-              <a:t>RECONCILE</a:t>
+              <a:t>DISCOVER</a:t>
             </a:r>
             <a:endParaRPr lang="en-US" sz="1000" dirty="0"/>
           </a:p>
@@ -12880,7 +12906,7 @@
                 <a:ea typeface="Inter" pitchFamily="34" charset="-122"/>
                 <a:cs typeface="Inter" pitchFamily="34" charset="-120"/>
               </a:rPr>
-              <a:t>Amounts, connected</a:t>
+              <a:t>Find liquidity</a:t>
             </a:r>
             <a:endParaRPr lang="en-US" sz="2300" dirty="0"/>
           </a:p>
@@ -12922,7 +12948,7 @@
                 <a:ea typeface="Inter" pitchFamily="34" charset="-122"/>
                 <a:cs typeface="Inter" pitchFamily="34" charset="-120"/>
               </a:rPr>
-              <a:t>Raw, standard and extension display in one view.</a:t>
+              <a:t>Filter tokenized-asset pools by issuer, pair and liquidity.</a:t>
             </a:r>
             <a:endParaRPr lang="en-US" sz="1600" dirty="0"/>
           </a:p>
@@ -12984,7 +13010,7 @@
                 <a:ea typeface="Inter" pitchFamily="34" charset="-122"/>
                 <a:cs typeface="Inter" pitchFamily="34" charset="-120"/>
               </a:rPr>
-              <a:t>INTERPRET</a:t>
+              <a:t>TRACE</a:t>
             </a:r>
             <a:endParaRPr lang="en-US" sz="1000" dirty="0"/>
           </a:p>
@@ -13023,7 +13049,7 @@
                 <a:ea typeface="Inter" pitchFamily="34" charset="-122"/>
                 <a:cs typeface="Inter" pitchFamily="34" charset="-120"/>
               </a:rPr>
-              <a:t>Controls, explained</a:t>
+              <a:t>Follow the source</a:t>
             </a:r>
             <a:endParaRPr lang="en-US" sz="2300" dirty="0"/>
           </a:p>
@@ -13065,7 +13091,7 @@
                 <a:ea typeface="Inter" pitchFamily="34" charset="-122"/>
                 <a:cs typeface="Inter" pitchFamily="34" charset="-120"/>
               </a:rPr>
-              <a:t>Technical configuration translated into operational meaning.</a:t>
+              <a:t>Inspect the exact mint. Open issuer reserve reports.</a:t>
             </a:r>
             <a:endParaRPr lang="en-US" sz="1600" dirty="0"/>
           </a:p>
@@ -13127,7 +13153,7 @@
                 <a:ea typeface="Inter" pitchFamily="34" charset="-122"/>
                 <a:cs typeface="Inter" pitchFamily="34" charset="-120"/>
               </a:rPr>
-              <a:t>RETAIN</a:t>
+              <a:t>TAKE IT WITH YOU</a:t>
             </a:r>
             <a:endParaRPr lang="en-US" sz="1000" dirty="0"/>
           </a:p>
@@ -13166,7 +13192,7 @@
                 <a:ea typeface="Inter" pitchFamily="34" charset="-122"/>
                 <a:cs typeface="Inter" pitchFamily="34" charset="-120"/>
               </a:rPr>
-              <a:t>Evidence, portable</a:t>
+              <a:t>Keep it close</a:t>
             </a:r>
             <a:endParaRPr lang="en-US" sz="2300" dirty="0"/>
           </a:p>
@@ -13208,7 +13234,7 @@
                 <a:ea typeface="Inter" pitchFamily="34" charset="-122"/>
                 <a:cs typeface="Inter" pitchFamily="34" charset="-120"/>
               </a:rPr>
-              <a:t>Source context and local JSON/CSV exports travel together.</a:t>
+              <a:t>Install the PWA. Carry JSON and CSV receipts.</a:t>
             </a:r>
             <a:endParaRPr lang="en-US" sz="1600" dirty="0"/>
           </a:p>

</xml_diff>